<commit_message>
decks: isekai-binary.pptx and agent-one-binary.pptx from one outline (build_binary.js), real captures and board screenshots
Co-Authored-By: Claude Opus 5.5 <noreply@anthropic.com>
</commit_message>
<xml_diff>
--- a/presentations/agent-one-binary.pptx
+++ b/presentations/agent-one-binary.pptx
@@ -520,7 +520,7 @@
           <a:p>
             <a:r>
               <a:rPr lang="en-US" dirty="0"/>
-              <a:t>Title. AGENT-ONE v0.1.1: a single static Go binary. Everything shown in this deck is captured from the released binary running in a demo workspace against a scripted OpenAI-compatible server.</a:t>
+              <a:t>Title. AGENT-ONE v0.1.2: a single static Go binary. Everything shown in this deck is captured from the released binary running in a demo workspace against a scripted OpenAI-compatible server.</a:t>
             </a:r>
             <a:endParaRPr lang="en-US" dirty="0"/>
           </a:p>
@@ -2651,7 +2651,7 @@
                 <a:ea typeface="Courier New" pitchFamily="34" charset="-122"/>
                 <a:cs typeface="Courier New" pitchFamily="34" charset="-120"/>
               </a:rPr>
-              <a:t>v0.1.1  ·  github.com/Kaginari/agent-one</a:t>
+              <a:t>v0.1.2  ·  github.com/Kaginari/agent-one</a:t>
             </a:r>
             <a:endParaRPr lang="en-US" sz="1100" dirty="0"/>
           </a:p>
@@ -6289,12 +6289,12 @@
         </p:nvSpPr>
         <p:spPr>
           <a:xfrm>
-            <a:off x="512064" y="1700784"/>
-            <a:ext cx="7479792" cy="4828032"/>
+            <a:off x="512064" y="1655064"/>
+            <a:ext cx="7159752" cy="4599432"/>
           </a:xfrm>
           <a:prstGeom prst="roundRect">
             <a:avLst>
-              <a:gd name="adj" fmla="val 1136"/>
+              <a:gd name="adj" fmla="val 1193"/>
             </a:avLst>
           </a:prstGeom>
           <a:solidFill>
@@ -6330,8 +6330,8 @@
         </p:blipFill>
         <p:spPr>
           <a:xfrm>
-            <a:off x="548640" y="1737360"/>
-            <a:ext cx="7406640" cy="4754880"/>
+            <a:off x="548640" y="1691640"/>
+            <a:ext cx="7086600" cy="4526280"/>
           </a:xfrm>
           <a:prstGeom prst="rect">
             <a:avLst/>
@@ -6346,12 +6346,12 @@
         </p:nvSpPr>
         <p:spPr>
           <a:xfrm>
-            <a:off x="8375904" y="1700784"/>
-            <a:ext cx="3273552" cy="4828032"/>
+            <a:off x="8284464" y="1655064"/>
+            <a:ext cx="3136392" cy="4599432"/>
           </a:xfrm>
           <a:prstGeom prst="roundRect">
             <a:avLst>
-              <a:gd name="adj" fmla="val 1676"/>
+              <a:gd name="adj" fmla="val 1749"/>
             </a:avLst>
           </a:prstGeom>
           <a:solidFill>
@@ -6387,8 +6387,8 @@
         </p:blipFill>
         <p:spPr>
           <a:xfrm>
-            <a:off x="8412480" y="1737360"/>
-            <a:ext cx="3200400" cy="4754880"/>
+            <a:off x="8321040" y="1691640"/>
+            <a:ext cx="3063240" cy="4526280"/>
           </a:xfrm>
           <a:prstGeom prst="rect">
             <a:avLst/>
@@ -7159,7 +7159,7 @@
                 <a:ea typeface="Cambria" pitchFamily="34" charset="-122"/>
                 <a:cs typeface="Cambria" pitchFamily="34" charset="-120"/>
               </a:rPr>
-              <a:t>9</a:t>
+              <a:t>9 + 8</a:t>
             </a:r>
             <a:endParaRPr lang="en-US" sz="4800" dirty="0"/>
           </a:p>
@@ -7198,7 +7198,7 @@
                 <a:ea typeface="Calibri" pitchFamily="34" charset="-122"/>
                 <a:cs typeface="Calibri" pitchFamily="34" charset="-120"/>
               </a:rPr>
-              <a:t>defects found by attack, fixed with tests</a:t>
+              <a:t>defects fixed: by attack, then by using the releases</a:t>
             </a:r>
             <a:endParaRPr lang="en-US" sz="1400" dirty="0"/>
           </a:p>
@@ -7319,7 +7319,7 @@
                 <a:ea typeface="Calibri" pitchFamily="34" charset="-122"/>
                 <a:cs typeface="Calibri" pitchFamily="34" charset="-120"/>
               </a:rPr>
-              <a:t>An independent validator attacked the gate, the sandbox, the permission rules, symlinks, secrets and injection — before release.</a:t>
+              <a:t>An independent validator attacked the gate, the sandbox, the permission rules, symlinks, secrets and injection — before release. Running the released binaries for this deck found the rest; each fix ships with a regression test.</a:t>
             </a:r>
             <a:endParaRPr lang="en-US" sz="1500" dirty="0"/>
           </a:p>
@@ -8964,7 +8964,7 @@
                 <a:ea typeface="Cambria" pitchFamily="34" charset="-122"/>
                 <a:cs typeface="Cambria" pitchFamily="34" charset="-120"/>
               </a:rPr>
-              <a:t>AGENT-ONE v0.1.1</a:t>
+              <a:t>AGENT-ONE v0.1.2</a:t>
             </a:r>
             <a:endParaRPr lang="en-US" sz="4000" dirty="0"/>
           </a:p>

</xml_diff>